<commit_message>
refactor: equalize team member roles across pipeline, web studio, docs, and generated output
</commit_message>
<xml_diff>
--- a/to be submitted/SmartScan_Project_Presentation.pptx
+++ b/to be submitted/SmartScan_Project_Presentation.pptx
@@ -3528,25 +3528,6 @@
                 </a:solidFill>
                 <a:latin typeface="Segoe UI"/>
               </a:rPr>
-              <a:t>• Himanshu Garg (E250 - Lead): </a:t>
-            </a:r>
-            <a:r>
-              <a:rPr b="0" sz="1200">
-                <a:solidFill>
-                  <a:srgbClr val="94A3B8"/>
-                </a:solidFill>
-                <a:latin typeface="Segoe UI"/>
-              </a:rPr>
-              <a:t>Morphology, DFT, HD Engine
-</a:t>
-            </a:r>
-            <a:r>
-              <a:rPr b="1" sz="1200">
-                <a:solidFill>
-                  <a:srgbClr val="FFFFFF"/>
-                </a:solidFill>
-                <a:latin typeface="Segoe UI"/>
-              </a:rPr>
               <a:t>• Parth Chaturvedi (E235): </a:t>
             </a:r>
             <a:r>
@@ -3576,6 +3557,25 @@
                 <a:latin typeface="Segoe UI"/>
               </a:rPr>
               <a:t>Edge Operators &amp; Adaptive Segmentation
+</a:t>
+            </a:r>
+            <a:r>
+              <a:rPr b="1" sz="1200">
+                <a:solidFill>
+                  <a:srgbClr val="FFFFFF"/>
+                </a:solidFill>
+                <a:latin typeface="Segoe UI"/>
+              </a:rPr>
+              <a:t>• Himanshu Garg (E250): </a:t>
+            </a:r>
+            <a:r>
+              <a:rPr b="0" sz="1200">
+                <a:solidFill>
+                  <a:srgbClr val="94A3B8"/>
+                </a:solidFill>
+                <a:latin typeface="Segoe UI"/>
+              </a:rPr>
+              <a:t>Morphology, DFT, HD Engine
 </a:t>
             </a:r>
             <a:r>
@@ -3987,7 +3987,7 @@
         <p:spPr>
           <a:xfrm>
             <a:off x="7086600" y="2011680"/>
-            <a:ext cx="3840480" cy="5120640"/>
+            <a:ext cx="3840480" cy="5920740"/>
           </a:xfrm>
           <a:prstGeom prst="rect">
             <a:avLst/>
@@ -5852,7 +5852,7 @@
             <a:br/>
             <a:br/>
             <a:r>
-              <a:t>• Himanshu Garg (Roll No. E250 - Project Lead):</a:t>
+              <a:t>• Himanshu Garg (Roll No. E250):</a:t>
             </a:r>
             <a:br/>
             <a:r>
@@ -9672,7 +9672,7 @@
         <p:spPr>
           <a:xfrm>
             <a:off x="1371600" y="4572000"/>
-            <a:ext cx="3840480" cy="5120640"/>
+            <a:ext cx="3840480" cy="5920740"/>
           </a:xfrm>
           <a:prstGeom prst="rect">
             <a:avLst/>
@@ -9827,7 +9827,7 @@
         <p:spPr>
           <a:xfrm>
             <a:off x="6949440" y="4572000"/>
-            <a:ext cx="3840480" cy="5120640"/>
+            <a:ext cx="3840480" cy="5920740"/>
           </a:xfrm>
           <a:prstGeom prst="rect">
             <a:avLst/>
@@ -10266,7 +10266,7 @@
         <p:spPr>
           <a:xfrm>
             <a:off x="6949440" y="4389120"/>
-            <a:ext cx="3840480" cy="5120640"/>
+            <a:ext cx="3840480" cy="5920740"/>
           </a:xfrm>
           <a:prstGeom prst="rect">
             <a:avLst/>
@@ -10655,7 +10655,7 @@
         <p:spPr>
           <a:xfrm>
             <a:off x="6949440" y="2011680"/>
-            <a:ext cx="3840480" cy="5120640"/>
+            <a:ext cx="3840480" cy="5920740"/>
           </a:xfrm>
           <a:prstGeom prst="rect">
             <a:avLst/>

</xml_diff>